<commit_message>
restore: original defence presentation
</commit_message>
<xml_diff>
--- a/presentations/odoo-mas-defense-fr.pptx
+++ b/presentations/odoo-mas-defense-fr.pptx
@@ -1,6 +1,6 @@
 
 <file path=ppt/presentation.xml><?xml version="1.0" encoding="utf-8"?>
-<p:presentation xmlns:a="http://schemas.openxmlformats.org/drawingml/2006/main" xmlns:r="http://schemas.openxmlformats.org/officeDocument/2006/relationships" xmlns:p="http://schemas.openxmlformats.org/presentationml/2006/main" removePersonalInfoOnSave="1" saveSubsetFonts="1" autoCompressPictures="0">
+<p:presentation xmlns:a="http://schemas.openxmlformats.org/drawingml/2006/main" xmlns:r="http://schemas.openxmlformats.org/officeDocument/2006/relationships" xmlns:p="http://schemas.openxmlformats.org/presentationml/2006/main" saveSubsetFonts="1" autoCompressPictures="0">
   <p:sldMasterIdLst>
     <p:sldMasterId id="2147483648" r:id="rId1"/>
   </p:sldMasterIdLst>
@@ -256,13 +256,13 @@
                   <c:v>0.96699999999999997</c:v>
                 </c:pt>
                 <c:pt idx="1">
-                  <c:v>0.76700000000000002</c:v>
+                  <c:v>[phone redacted]00000002</c:v>
                 </c:pt>
                 <c:pt idx="2">
                   <c:v>0.8</c:v>
                 </c:pt>
                 <c:pt idx="3">
-                  <c:v>0.66700000000000004</c:v>
+                  <c:v>[phone redacted]00000004</c:v>
                 </c:pt>
                 <c:pt idx="4">
                   <c:v>0.92</c:v>
@@ -13137,7 +13137,7 @@
           <p:cNvPr id="40" name="Text 31">
             <a:extLst>
               <a:ext uri="{FF2B5EF4-FFF2-40B4-BE49-F238E27FC236}">
-                <a16:creationId xmlns:a16="http://schemas.microsoft.com/office/drawing/2014/main" id="{0FC6CD22-C290-13C5-B306-075452334144}"/>
+                <a16:creationId xmlns:a16="http://schemas.microsoft.com/office/drawing/2014/main" id="{0FC6CD22-C290-13C5-B3[phone redacted]4144}"/>
               </a:ext>
             </a:extLst>
           </p:cNvPr>
@@ -19403,7 +19403,7 @@
         <a:font script="Tfng" typeface="Ebrima"/>
       </a:majorFont>
       <a:minorFont>
-        <a:latin typeface="Calibri" panose="020F0502020204030204"/>
+        <a:latin typeface="Calibri" panose="020F[phone redacted]030204"/>
         <a:ea typeface=""/>
         <a:cs typeface=""/>
         <a:font script="Jpan" typeface="游ゴシック"/>

</xml_diff>